<commit_message>
adding preprocessing points in ppt
</commit_message>
<xml_diff>
--- a/source/MySEProject/Documentation/Presentation_SE finalllll.pptx
+++ b/source/MySEProject/Documentation/Presentation_SE finalllll.pptx
@@ -7947,13 +7947,182 @@
         </p:nvSpPr>
         <p:spPr>
           <a:xfrm>
-            <a:off x="677334" y="2160590"/>
-            <a:ext cx="8596668" cy="2767012"/>
+            <a:off x="677334" y="1723869"/>
+            <a:ext cx="8596668" cy="3203733"/>
           </a:xfrm>
         </p:spPr>
         <p:txBody>
           <a:bodyPr/>
           <a:lstStyle/>
+          <a:p>
+            <a:pPr marL="0" marR="0" algn="l" latinLnBrk="1">
+              <a:buNone/>
+              <a:tabLst>
+                <a:tab pos="581660" algn="l"/>
+                <a:tab pos="1163320" algn="l"/>
+                <a:tab pos="1744980" algn="l"/>
+                <a:tab pos="2326640" algn="l"/>
+                <a:tab pos="2908300" algn="l"/>
+                <a:tab pos="3489960" algn="l"/>
+                <a:tab pos="4071620" algn="l"/>
+                <a:tab pos="4653280" algn="l"/>
+                <a:tab pos="5234940" algn="l"/>
+                <a:tab pos="5816600" algn="l"/>
+                <a:tab pos="6398260" algn="l"/>
+                <a:tab pos="6979920" algn="l"/>
+                <a:tab pos="7561580" algn="l"/>
+                <a:tab pos="8143240" algn="l"/>
+                <a:tab pos="8724900" algn="l"/>
+                <a:tab pos="9306560" algn="l"/>
+              </a:tabLst>
+            </a:pPr>
+            <a:r>
+              <a:rPr lang="en-US" sz="1800" dirty="0">
+                <a:solidFill>
+                  <a:schemeClr val="tx1"/>
+                </a:solidFill>
+                <a:effectLst/>
+                <a:ea typeface="Times New Roman" panose="02020603050405020304" pitchFamily="18" charset="0"/>
+              </a:rPr>
+              <a:t>We present a working HTM implementation for temporal anomaly detection, demonstrating effective pattern learning through spatial-temporal processing. Future work will address:</a:t>
+            </a:r>
+            <a:endParaRPr lang="en-US" sz="1800" dirty="0">
+              <a:solidFill>
+                <a:schemeClr val="tx1"/>
+              </a:solidFill>
+              <a:effectLst/>
+              <a:ea typeface="SimSun" panose="02010600030101010101" pitchFamily="2" charset="-122"/>
+            </a:endParaRPr>
+          </a:p>
+          <a:p>
+            <a:pPr marL="342900" marR="0" lvl="0" indent="-342900" algn="l" latinLnBrk="1">
+              <a:buSzPts val="1000"/>
+              <a:buFont typeface="Symbol" panose="05050102010706020507" pitchFamily="18" charset="2"/>
+              <a:buChar char=""/>
+              <a:tabLst>
+                <a:tab pos="457200" algn="l"/>
+                <a:tab pos="581660" algn="l"/>
+                <a:tab pos="1163320" algn="l"/>
+                <a:tab pos="1744980" algn="l"/>
+                <a:tab pos="2326640" algn="l"/>
+                <a:tab pos="2908300" algn="l"/>
+                <a:tab pos="3489960" algn="l"/>
+                <a:tab pos="4071620" algn="l"/>
+                <a:tab pos="4653280" algn="l"/>
+                <a:tab pos="5234940" algn="l"/>
+                <a:tab pos="5816600" algn="l"/>
+                <a:tab pos="6398260" algn="l"/>
+                <a:tab pos="6979920" algn="l"/>
+                <a:tab pos="7561580" algn="l"/>
+                <a:tab pos="8143240" algn="l"/>
+                <a:tab pos="8724900" algn="l"/>
+                <a:tab pos="9306560" algn="l"/>
+              </a:tabLst>
+            </a:pPr>
+            <a:r>
+              <a:rPr lang="en-US" sz="1800" dirty="0">
+                <a:solidFill>
+                  <a:schemeClr val="tx1"/>
+                </a:solidFill>
+                <a:effectLst/>
+                <a:ea typeface="Times New Roman" panose="02020603050405020304" pitchFamily="18" charset="0"/>
+              </a:rPr>
+              <a:t>Dynamic threshold adaptation</a:t>
+            </a:r>
+            <a:endParaRPr lang="en-US" sz="1800" dirty="0">
+              <a:solidFill>
+                <a:schemeClr val="tx1"/>
+              </a:solidFill>
+              <a:effectLst/>
+              <a:ea typeface="SimSun" panose="02010600030101010101" pitchFamily="2" charset="-122"/>
+            </a:endParaRPr>
+          </a:p>
+          <a:p>
+            <a:pPr marL="342900" marR="0" lvl="0" indent="-342900" algn="l" latinLnBrk="1">
+              <a:buSzPts val="1000"/>
+              <a:buFont typeface="Symbol" panose="05050102010706020507" pitchFamily="18" charset="2"/>
+              <a:buChar char=""/>
+              <a:tabLst>
+                <a:tab pos="457200" algn="l"/>
+                <a:tab pos="581660" algn="l"/>
+                <a:tab pos="1163320" algn="l"/>
+                <a:tab pos="1744980" algn="l"/>
+                <a:tab pos="2326640" algn="l"/>
+                <a:tab pos="2908300" algn="l"/>
+                <a:tab pos="3489960" algn="l"/>
+                <a:tab pos="4071620" algn="l"/>
+                <a:tab pos="4653280" algn="l"/>
+                <a:tab pos="5234940" algn="l"/>
+                <a:tab pos="5816600" algn="l"/>
+                <a:tab pos="6398260" algn="l"/>
+                <a:tab pos="6979920" algn="l"/>
+                <a:tab pos="7561580" algn="l"/>
+                <a:tab pos="8143240" algn="l"/>
+                <a:tab pos="8724900" algn="l"/>
+                <a:tab pos="9306560" algn="l"/>
+              </a:tabLst>
+            </a:pPr>
+            <a:r>
+              <a:rPr lang="en-US" sz="1800" dirty="0">
+                <a:solidFill>
+                  <a:schemeClr val="tx1"/>
+                </a:solidFill>
+                <a:effectLst/>
+                <a:ea typeface="Times New Roman" panose="02020603050405020304" pitchFamily="18" charset="0"/>
+              </a:rPr>
+              <a:t>Distributed training</a:t>
+            </a:r>
+            <a:endParaRPr lang="en-US" sz="1800" dirty="0">
+              <a:solidFill>
+                <a:schemeClr val="tx1"/>
+              </a:solidFill>
+              <a:effectLst/>
+              <a:ea typeface="SimSun" panose="02010600030101010101" pitchFamily="2" charset="-122"/>
+            </a:endParaRPr>
+          </a:p>
+          <a:p>
+            <a:pPr marL="342900" marR="0" lvl="0" indent="-342900" algn="l" latinLnBrk="1">
+              <a:buSzPts val="1000"/>
+              <a:buFont typeface="Symbol" panose="05050102010706020507" pitchFamily="18" charset="2"/>
+              <a:buChar char=""/>
+              <a:tabLst>
+                <a:tab pos="457200" algn="l"/>
+                <a:tab pos="581660" algn="l"/>
+                <a:tab pos="1163320" algn="l"/>
+                <a:tab pos="1744980" algn="l"/>
+                <a:tab pos="2326640" algn="l"/>
+                <a:tab pos="2908300" algn="l"/>
+                <a:tab pos="3489960" algn="l"/>
+                <a:tab pos="4071620" algn="l"/>
+                <a:tab pos="4653280" algn="l"/>
+                <a:tab pos="5234940" algn="l"/>
+                <a:tab pos="5816600" algn="l"/>
+                <a:tab pos="6398260" algn="l"/>
+                <a:tab pos="6979920" algn="l"/>
+                <a:tab pos="7561580" algn="l"/>
+                <a:tab pos="8143240" algn="l"/>
+                <a:tab pos="8724900" algn="l"/>
+                <a:tab pos="9306560" algn="l"/>
+              </a:tabLst>
+            </a:pPr>
+            <a:r>
+              <a:rPr lang="en-US" sz="1800" dirty="0">
+                <a:solidFill>
+                  <a:schemeClr val="tx1"/>
+                </a:solidFill>
+                <a:effectLst/>
+                <a:ea typeface="Times New Roman" panose="02020603050405020304" pitchFamily="18" charset="0"/>
+              </a:rPr>
+              <a:t>Streaming data support</a:t>
+            </a:r>
+            <a:endParaRPr lang="en-US" sz="1800" dirty="0">
+              <a:solidFill>
+                <a:schemeClr val="tx1"/>
+              </a:solidFill>
+              <a:effectLst/>
+              <a:ea typeface="SimSun" panose="02010600030101010101" pitchFamily="2" charset="-122"/>
+            </a:endParaRPr>
+          </a:p>
           <a:p>
             <a:endParaRPr lang="en-US" dirty="0"/>
           </a:p>

</xml_diff>

<commit_message>
add HTM graph in ppt
</commit_message>
<xml_diff>
--- a/source/MySEProject/Documentation/Presentation_SE finalllll.pptx
+++ b/source/MySEProject/Documentation/Presentation_SE finalllll.pptx
@@ -7995,10 +7995,10 @@
             </a:endParaRPr>
           </a:p>
           <a:p>
-            <a:pPr marL="342900" marR="0" lvl="0" indent="-342900" algn="l" latinLnBrk="1">
+            <a:pPr marR="0" lvl="0" algn="l" latinLnBrk="1">
               <a:buSzPts val="1000"/>
-              <a:buFont typeface="Symbol" panose="05050102010706020507" pitchFamily="18" charset="2"/>
-              <a:buChar char=""/>
+              <a:buFont typeface="Wingdings" panose="05000000000000000000" pitchFamily="2" charset="2"/>
+              <a:buChar char="Ø"/>
               <a:tabLst>
                 <a:tab pos="457200" algn="l"/>
                 <a:tab pos="581660" algn="l"/>
@@ -8038,10 +8038,10 @@
             </a:endParaRPr>
           </a:p>
           <a:p>
-            <a:pPr marL="342900" marR="0" lvl="0" indent="-342900" algn="l" latinLnBrk="1">
+            <a:pPr marR="0" lvl="0" algn="l" latinLnBrk="1">
               <a:buSzPts val="1000"/>
-              <a:buFont typeface="Symbol" panose="05050102010706020507" pitchFamily="18" charset="2"/>
-              <a:buChar char=""/>
+              <a:buFont typeface="Wingdings" panose="05000000000000000000" pitchFamily="2" charset="2"/>
+              <a:buChar char="Ø"/>
               <a:tabLst>
                 <a:tab pos="457200" algn="l"/>
                 <a:tab pos="581660" algn="l"/>
@@ -8081,10 +8081,10 @@
             </a:endParaRPr>
           </a:p>
           <a:p>
-            <a:pPr marL="342900" marR="0" lvl="0" indent="-342900" algn="l" latinLnBrk="1">
+            <a:pPr marR="0" lvl="0" algn="l" latinLnBrk="1">
               <a:buSzPts val="1000"/>
-              <a:buFont typeface="Symbol" panose="05050102010706020507" pitchFamily="18" charset="2"/>
-              <a:buChar char=""/>
+              <a:buFont typeface="Wingdings" panose="05000000000000000000" pitchFamily="2" charset="2"/>
+              <a:buChar char="Ø"/>
               <a:tabLst>
                 <a:tab pos="457200" algn="l"/>
                 <a:tab pos="581660" algn="l"/>

</xml_diff>

<commit_message>
add anomaly detection logic in presentation
</commit_message>
<xml_diff>
--- a/source/MySEProject/Documentation/Presentation_SE finalllll.pptx
+++ b/source/MySEProject/Documentation/Presentation_SE finalllll.pptx
@@ -8398,10 +8398,7 @@
           <a:lstStyle/>
           <a:p>
             <a:pPr algn="ctr"/>
-            <a:r>
-              <a:rPr lang="en-US" sz="7200" dirty="0"/>
-              <a:t>Thank You!</a:t>
-            </a:r>
+            <a:endParaRPr lang="en-US" sz="7200" dirty="0"/>
           </a:p>
         </p:txBody>
       </p:sp>

</xml_diff>

<commit_message>
Adding Project Workflow to the slide
</commit_message>
<xml_diff>
--- a/source/MySEProject/Documentation/Presentation_SE finalllll.pptx
+++ b/source/MySEProject/Documentation/Presentation_SE finalllll.pptx
@@ -8398,7 +8398,10 @@
           <a:lstStyle/>
           <a:p>
             <a:pPr algn="ctr"/>
-            <a:endParaRPr lang="en-US" sz="7200" dirty="0"/>
+            <a:r>
+              <a:rPr lang="en-US" sz="7200" dirty="0"/>
+              <a:t>Thank You!</a:t>
+            </a:r>
           </a:p>
         </p:txBody>
       </p:sp>

</xml_diff>

<commit_message>
Summarizing the processing elements
</commit_message>
<xml_diff>
--- a/source/MySEProject/Documentation/Presentation_SE finalllll.pptx
+++ b/source/MySEProject/Documentation/Presentation_SE finalllll.pptx
@@ -7263,42 +7263,6 @@
           <a:chExt cx="0" cy="0"/>
         </a:xfrm>
       </p:grpSpPr>
-      <p:pic>
-        <p:nvPicPr>
-          <p:cNvPr id="4" name="Picture 3" descr="A graph showing a number of different colored lines">
-            <a:extLst>
-              <a:ext uri="{FF2B5EF4-FFF2-40B4-BE49-F238E27FC236}">
-                <a16:creationId xmlns:a16="http://schemas.microsoft.com/office/drawing/2014/main" id="{AC882C45-61F9-119B-510F-36C30C98A8F7}"/>
-              </a:ext>
-            </a:extLst>
-          </p:cNvPr>
-          <p:cNvPicPr>
-            <a:picLocks noChangeAspect="1"/>
-          </p:cNvPicPr>
-          <p:nvPr/>
-        </p:nvPicPr>
-        <p:blipFill>
-          <a:blip r:embed="rId3">
-            <a:extLst>
-              <a:ext uri="{28A0092B-C50C-407E-A947-70E740481C1C}">
-                <a14:useLocalDpi xmlns:a14="http://schemas.microsoft.com/office/drawing/2010/main" val="0"/>
-              </a:ext>
-            </a:extLst>
-          </a:blip>
-          <a:stretch>
-            <a:fillRect/>
-          </a:stretch>
-        </p:blipFill>
-        <p:spPr>
-          <a:xfrm>
-            <a:off x="317968" y="1433671"/>
-            <a:ext cx="9023402" cy="4535990"/>
-          </a:xfrm>
-          <a:prstGeom prst="rect">
-            <a:avLst/>
-          </a:prstGeom>
-        </p:spPr>
-      </p:pic>
       <p:sp>
         <p:nvSpPr>
           <p:cNvPr id="2" name="Title 1">
@@ -7349,7 +7313,7 @@
           <p:nvPr/>
         </p:nvPicPr>
         <p:blipFill>
-          <a:blip r:embed="rId4">
+          <a:blip r:embed="rId3">
             <a:extLst>
               <a:ext uri="{28A0092B-C50C-407E-A947-70E740481C1C}">
                 <a14:useLocalDpi xmlns:a14="http://schemas.microsoft.com/office/drawing/2010/main" val="0"/>

</xml_diff>

<commit_message>
add actual vs predicted values and anomaly flag in ppt
</commit_message>
<xml_diff>
--- a/source/MySEProject/Documentation/Presentation_SE finalllll.pptx
+++ b/source/MySEProject/Documentation/Presentation_SE finalllll.pptx
@@ -7263,6 +7263,42 @@
           <a:chExt cx="0" cy="0"/>
         </a:xfrm>
       </p:grpSpPr>
+      <p:pic>
+        <p:nvPicPr>
+          <p:cNvPr id="4" name="Picture 3" descr="A graph showing a number of different colored lines">
+            <a:extLst>
+              <a:ext uri="{FF2B5EF4-FFF2-40B4-BE49-F238E27FC236}">
+                <a16:creationId xmlns:a16="http://schemas.microsoft.com/office/drawing/2014/main" id="{AC882C45-61F9-119B-510F-36C30C98A8F7}"/>
+              </a:ext>
+            </a:extLst>
+          </p:cNvPr>
+          <p:cNvPicPr>
+            <a:picLocks noChangeAspect="1"/>
+          </p:cNvPicPr>
+          <p:nvPr/>
+        </p:nvPicPr>
+        <p:blipFill>
+          <a:blip r:embed="rId3">
+            <a:extLst>
+              <a:ext uri="{28A0092B-C50C-407E-A947-70E740481C1C}">
+                <a14:useLocalDpi xmlns:a14="http://schemas.microsoft.com/office/drawing/2010/main" val="0"/>
+              </a:ext>
+            </a:extLst>
+          </a:blip>
+          <a:stretch>
+            <a:fillRect/>
+          </a:stretch>
+        </p:blipFill>
+        <p:spPr>
+          <a:xfrm>
+            <a:off x="317968" y="1433671"/>
+            <a:ext cx="9023402" cy="4535990"/>
+          </a:xfrm>
+          <a:prstGeom prst="rect">
+            <a:avLst/>
+          </a:prstGeom>
+        </p:spPr>
+      </p:pic>
       <p:sp>
         <p:nvSpPr>
           <p:cNvPr id="2" name="Title 1">
@@ -7313,7 +7349,7 @@
           <p:nvPr/>
         </p:nvPicPr>
         <p:blipFill>
-          <a:blip r:embed="rId3">
+          <a:blip r:embed="rId4">
             <a:extLst>
               <a:ext uri="{28A0092B-C50C-407E-A947-70E740481C1C}">
                 <a14:useLocalDpi xmlns:a14="http://schemas.microsoft.com/office/drawing/2010/main" val="0"/>

</xml_diff>

<commit_message>
adding line charts, results and conclusion
</commit_message>
<xml_diff>
--- a/source/MySEProject/Documentation/Presentation_SE finalllll.pptx
+++ b/source/MySEProject/Documentation/Presentation_SE finalllll.pptx
@@ -7263,42 +7263,6 @@
           <a:chExt cx="0" cy="0"/>
         </a:xfrm>
       </p:grpSpPr>
-      <p:pic>
-        <p:nvPicPr>
-          <p:cNvPr id="4" name="Picture 3" descr="A graph showing a number of different colored lines">
-            <a:extLst>
-              <a:ext uri="{FF2B5EF4-FFF2-40B4-BE49-F238E27FC236}">
-                <a16:creationId xmlns:a16="http://schemas.microsoft.com/office/drawing/2014/main" id="{AC882C45-61F9-119B-510F-36C30C98A8F7}"/>
-              </a:ext>
-            </a:extLst>
-          </p:cNvPr>
-          <p:cNvPicPr>
-            <a:picLocks noChangeAspect="1"/>
-          </p:cNvPicPr>
-          <p:nvPr/>
-        </p:nvPicPr>
-        <p:blipFill>
-          <a:blip r:embed="rId3">
-            <a:extLst>
-              <a:ext uri="{28A0092B-C50C-407E-A947-70E740481C1C}">
-                <a14:useLocalDpi xmlns:a14="http://schemas.microsoft.com/office/drawing/2010/main" val="0"/>
-              </a:ext>
-            </a:extLst>
-          </a:blip>
-          <a:stretch>
-            <a:fillRect/>
-          </a:stretch>
-        </p:blipFill>
-        <p:spPr>
-          <a:xfrm>
-            <a:off x="317968" y="1433671"/>
-            <a:ext cx="9023402" cy="4535990"/>
-          </a:xfrm>
-          <a:prstGeom prst="rect">
-            <a:avLst/>
-          </a:prstGeom>
-        </p:spPr>
-      </p:pic>
       <p:sp>
         <p:nvSpPr>
           <p:cNvPr id="2" name="Title 1">
@@ -7349,7 +7313,7 @@
           <p:nvPr/>
         </p:nvPicPr>
         <p:blipFill>
-          <a:blip r:embed="rId4">
+          <a:blip r:embed="rId3">
             <a:extLst>
               <a:ext uri="{28A0092B-C50C-407E-A947-70E740481C1C}">
                 <a14:useLocalDpi xmlns:a14="http://schemas.microsoft.com/office/drawing/2010/main" val="0"/>

</xml_diff>

<commit_message>
Add project video presentaion
</commit_message>
<xml_diff>
--- a/source/MySEProject/Documentation/Presentation_SE finalllll.pptx
+++ b/source/MySEProject/Documentation/Presentation_SE finalllll.pptx
@@ -16916,6 +16916,39 @@
       </p:pic>
       <p:sp>
         <p:nvSpPr>
+          <p:cNvPr id="6" name="Title 1">
+            <a:extLst>
+              <a:ext uri="{FF2B5EF4-FFF2-40B4-BE49-F238E27FC236}">
+                <a16:creationId xmlns:a16="http://schemas.microsoft.com/office/drawing/2014/main" id="{CA7554C7-C95F-1A1E-5FE5-7F0D7BA524D5}"/>
+              </a:ext>
+            </a:extLst>
+          </p:cNvPr>
+          <p:cNvSpPr>
+            <a:spLocks noGrp="1"/>
+          </p:cNvSpPr>
+          <p:nvPr>
+            <p:ph type="title"/>
+          </p:nvPr>
+        </p:nvSpPr>
+        <p:spPr>
+          <a:xfrm>
+            <a:off x="640919" y="172390"/>
+            <a:ext cx="8596668" cy="1320800"/>
+          </a:xfrm>
+        </p:spPr>
+        <p:txBody>
+          <a:bodyPr/>
+          <a:lstStyle/>
+          <a:p>
+            <a:r>
+              <a:rPr lang="en-US" dirty="0"/>
+              <a:t>Processing Elements</a:t>
+            </a:r>
+          </a:p>
+        </p:txBody>
+      </p:sp>
+      <p:sp>
+        <p:nvSpPr>
           <p:cNvPr id="12" name="Footer Placeholder 5">
             <a:extLst>
               <a:ext uri="{FF2B5EF4-FFF2-40B4-BE49-F238E27FC236}">
@@ -17086,31 +17119,6 @@
                 <a:schemeClr val="tx1"/>
               </a:solidFill>
             </a:endParaRPr>
-          </a:p>
-        </p:txBody>
-      </p:sp>
-      <p:sp>
-        <p:nvSpPr>
-          <p:cNvPr id="3" name="Title 2">
-            <a:extLst>
-              <a:ext uri="{FF2B5EF4-FFF2-40B4-BE49-F238E27FC236}">
-                <a16:creationId xmlns:a16="http://schemas.microsoft.com/office/drawing/2014/main" id="{0AF94277-3A10-2E0C-67F3-0A3163F5CF73}"/>
-              </a:ext>
-            </a:extLst>
-          </p:cNvPr>
-          <p:cNvSpPr>
-            <a:spLocks noGrp="1"/>
-          </p:cNvSpPr>
-          <p:nvPr>
-            <p:ph type="title"/>
-          </p:nvPr>
-        </p:nvSpPr>
-        <p:spPr/>
-        <p:txBody>
-          <a:bodyPr/>
-          <a:lstStyle/>
-          <a:p>
-            <a:endParaRPr lang="en-US"/>
           </a:p>
         </p:txBody>
       </p:sp>

</xml_diff>